<commit_message>
docs(presentation): update PPTX investor deck, generator script, and slide speaking notes with zero-latency fallbacks and quota resilience
</commit_message>
<xml_diff>
--- a/Ag_Extension_Investor_Deck.pptx
+++ b/Ag_Extension_Investor_Deck.pptx
@@ -3698,7 +3698,7 @@
               </a:defRPr>
             </a:pPr>
             <a:r>
-              <a:t>• Non-Dilutive R&amp;D Salary Co-Funding:</a:t>
+              <a:t>• Quota Resilience &amp; Non-Dilutive R&amp;D:</a:t>
             </a:r>
           </a:p>
           <a:p>
@@ -3710,7 +3710,7 @@
               </a:defRPr>
             </a:pPr>
             <a:r>
-              <a:t>IRAP co-funds Canadian AI software engineers, data scientists &amp; Indigenous knowledge specialists creating IP in Canada.</a:t>
+              <a:t>OmniRoute default quota engine prevents 403 authorization failures; IRAP co-funds Canadian AI engineers &amp; Indigenous specialists.</a:t>
             </a:r>
           </a:p>
         </p:txBody>
@@ -4395,7 +4395,7 @@
               </a:defRPr>
             </a:pPr>
             <a:r>
-              <a:t>2-Second Leaf Disease Diagnostics:</a:t>
+              <a:t>2-Second Diagnostics &amp; Instant Fallbacks:</a:t>
             </a:r>
           </a:p>
           <a:p>
@@ -4407,7 +4407,7 @@
               </a:defRPr>
             </a:pPr>
             <a:r>
-              <a:t>Snap a photo of an unhealthy crop to receive immediate computer vision diagnosis and treatment advice.</a:t>
+              <a:t>Snap a crop photo for immediate CV diagnosis, backed by zero-latency fallback state handling to ensure 100% report uptime.</a:t>
             </a:r>
           </a:p>
         </p:txBody>
@@ -4539,7 +4539,7 @@
               </a:defRPr>
             </a:pPr>
             <a:r>
-              <a:t>Runs over WhatsApp, SMS, or voice notes — built for rural low-connectivity environments.</a:t>
+              <a:t>Runs over WhatsApp, SMS, or voice notes — built for rural low-connectivity environments across the globe.</a:t>
             </a:r>
           </a:p>
         </p:txBody>
@@ -4770,7 +4770,7 @@
               </a:defRPr>
             </a:pPr>
             <a:r>
-              <a:t>Multi-agent engine, 21+ MCP tools, and multi-channel UI fully functional.</a:t>
+              <a:t>Multi-agent engine, 21+ MCP tools, instant report fallbacks, and multi-channel UI fully functional.</a:t>
             </a:r>
           </a:p>
         </p:txBody>

</xml_diff>